<commit_message>
test: verify pptx multi-run editing
</commit_message>
<xml_diff>
--- a/crates/opensuite-pptx/tests/fixtures/realistic-presentation.pptx
+++ b/crates/opensuite-pptx/tests/fixtures/realistic-presentation.pptx
@@ -2,15 +2,15 @@
 <file path=ppt/presentation.xml><?xml version="1.0" encoding="utf-8"?>
 <p:presentation xmlns:p="http://schemas.openxmlformats.org/presentationml/2006/main">
   <p:sldMasterIdLst>
-    <p:sldMasterId xmlns:r="http://schemas.openxmlformats.org/officeDocument/2006/relationships" id="2147483648" r:id="Rd71621bd94ee4810"/>
+    <p:sldMasterId xmlns:r="http://schemas.openxmlformats.org/officeDocument/2006/relationships" id="2147483648" r:id="R5e9524203d054624"/>
   </p:sldMasterIdLst>
   <p:notesMasterIdLst>
-    <p:notesMasterId xmlns:r="http://schemas.openxmlformats.org/officeDocument/2006/relationships" r:id="R43d9a387aebd4ba6"/>
+    <p:notesMasterId xmlns:r="http://schemas.openxmlformats.org/officeDocument/2006/relationships" r:id="R5a971240d0a44ef9"/>
   </p:notesMasterIdLst>
   <p:sldIdLst>
-    <p:sldId xmlns:r="http://schemas.openxmlformats.org/officeDocument/2006/relationships" id="256" r:id="Red9f5cc33adc44e7"/>
-    <p:sldId xmlns:r="http://schemas.openxmlformats.org/officeDocument/2006/relationships" id="257" r:id="Rf4042d279678476a"/>
-    <p:sldId xmlns:r="http://schemas.openxmlformats.org/officeDocument/2006/relationships" id="258" r:id="R1b8a7d0109384a97"/>
+    <p:sldId xmlns:r="http://schemas.openxmlformats.org/officeDocument/2006/relationships" id="256" r:id="R75283acdb9df4d74"/>
+    <p:sldId xmlns:r="http://schemas.openxmlformats.org/officeDocument/2006/relationships" id="257" r:id="Rf62530cec28b4f4a"/>
+    <p:sldId xmlns:r="http://schemas.openxmlformats.org/officeDocument/2006/relationships" id="258" r:id="R670978202e4f4325"/>
   </p:sldIdLst>
   <p:sldSz cx="12192000" cy="6858000"/>
   <p:notesSz cx="6858000" cy="9144000"/>
@@ -640,7 +640,7 @@
   </p:cSld>
   <p:clrMap bg1="lt1" tx1="dk1" bg2="lt2" tx2="dk2" accent1="accent1" accent2="accent2" accent3="accent3" accent4="accent4" accent5="accent5" accent6="accent6" hlink="hlink" folHlink="folHlink"/>
   <p:sldLayoutIdLst>
-    <p:sldLayoutId xmlns:r="http://schemas.openxmlformats.org/officeDocument/2006/relationships" id="2147483649" r:id="R3e91e0d0cc8c4056"/>
+    <p:sldLayoutId xmlns:r="http://schemas.openxmlformats.org/officeDocument/2006/relationships" id="2147483649" r:id="R6e82f834890d4d21"/>
   </p:sldLayoutIdLst>
   <p:txStyles>
     <p:titleStyle>
@@ -1324,7 +1324,7 @@
           <p:cNvPr id="4" name="Title placeholder">
             <a:extLst xmlns:a="http://schemas.openxmlformats.org/drawingml/2006/main">
               <a:ext uri="{FF2B5EF4-FFF2-40B4-BE49-F238E27FC236}">
-                <a16:creationId xmlns:a16="http://schemas.microsoft.com/office/drawing/2014/main" id="{71BB5F3F-A590-45E5-BA55-75E1CC5A9FFD}"/>
+                <a16:creationId xmlns:a16="http://schemas.microsoft.com/office/drawing/2014/main" id="{93E4EDB8-D626-480C-B1D0-86BB8DB01F6F}"/>
               </a:ext>
             </a:extLst>
           </p:cNvPr>
@@ -1380,7 +1380,7 @@
           <p:cNvPr id="2" name="Body placeholder">
             <a:extLst xmlns:a="http://schemas.openxmlformats.org/drawingml/2006/main">
               <a:ext uri="{FF2B5EF4-FFF2-40B4-BE49-F238E27FC236}">
-                <a16:creationId xmlns:a16="http://schemas.microsoft.com/office/drawing/2014/main" id="{3DAA466F-158B-46E0-9DE6-1337E31DC70C}"/>
+                <a16:creationId xmlns:a16="http://schemas.microsoft.com/office/drawing/2014/main" id="{0B4E966E-730F-4AC9-B36D-19622C3901DE}"/>
               </a:ext>
             </a:extLst>
           </p:cNvPr>
@@ -1437,7 +1437,7 @@
                 <a:ea typeface="Aptos"/>
                 <a:cs typeface="Aptos"/>
               </a:rPr>
-              <a:t>&amp; source</a:t>
+              <a:t>&amp; source remains</a:t>
             </a:r>
           </a:p>
           <a:p xmlns:a="http://schemas.openxmlformats.org/drawingml/2006/main">
@@ -1477,14 +1477,14 @@
         </p:xfrm>
         <a:graphic xmlns:a="http://schemas.openxmlformats.org/drawingml/2006/main">
           <a:graphicData uri="http://schemas.openxmlformats.org/drawingml/2006/chart">
-            <c:chart xmlns:r="http://schemas.openxmlformats.org/officeDocument/2006/relationships" xmlns:c="http://schemas.openxmlformats.org/drawingml/2006/chart" r:id="R3cbaa510f7454b68"/>
+            <c:chart xmlns:r="http://schemas.openxmlformats.org/officeDocument/2006/relationships" xmlns:c="http://schemas.openxmlformats.org/drawingml/2006/chart" r:id="R1404b4c5d2ae4ace"/>
           </a:graphicData>
         </a:graphic>
       </p:graphicFrame>
     </p:spTree>
     <p:extLst>
       <p:ext uri="{BB962C8B-B14F-4D97-AF65-F5344CB8AC3E}">
-        <p14:creationId xmlns:p14="http://schemas.microsoft.com/office/powerpoint/2010/main" val="978523245"/>
+        <p14:creationId xmlns:p14="http://schemas.microsoft.com/office/powerpoint/2010/main" val="630832148"/>
       </p:ext>
     </p:extLst>
   </p:cSld>
@@ -1515,7 +1515,7 @@
           <p:cNvPr id="3" name="Slide two title">
             <a:extLst xmlns:a="http://schemas.openxmlformats.org/drawingml/2006/main">
               <a:ext uri="{FF2B5EF4-FFF2-40B4-BE49-F238E27FC236}">
-                <a16:creationId xmlns:a16="http://schemas.microsoft.com/office/drawing/2014/main" id="{A6946DC4-352F-48FA-AEEE-302C74051864}"/>
+                <a16:creationId xmlns:a16="http://schemas.microsoft.com/office/drawing/2014/main" id="{AABB12F9-701E-4298-A6B5-32F0BE21F436}"/>
               </a:ext>
             </a:extLst>
           </p:cNvPr>
@@ -1571,7 +1571,7 @@
           <p:cNvPr id="2" name="Slide two text">
             <a:extLst xmlns:a="http://schemas.openxmlformats.org/drawingml/2006/main">
               <a:ext uri="{FF2B5EF4-FFF2-40B4-BE49-F238E27FC236}">
-                <a16:creationId xmlns:a16="http://schemas.microsoft.com/office/drawing/2014/main" id="{82DC6A65-1FD3-4FD4-8BF9-72CF48258D62}"/>
+                <a16:creationId xmlns:a16="http://schemas.microsoft.com/office/drawing/2014/main" id="{E7306193-C6B6-4E2F-9E20-9F4FB4FA6480}"/>
               </a:ext>
             </a:extLst>
           </p:cNvPr>
@@ -1625,7 +1625,7 @@
     </p:spTree>
     <p:extLst>
       <p:ext uri="{BB962C8B-B14F-4D97-AF65-F5344CB8AC3E}">
-        <p14:creationId xmlns:p14="http://schemas.microsoft.com/office/powerpoint/2010/main" val="949005272"/>
+        <p14:creationId xmlns:p14="http://schemas.microsoft.com/office/powerpoint/2010/main" val="904966072"/>
       </p:ext>
     </p:extLst>
   </p:cSld>
@@ -1656,7 +1656,7 @@
           <p:cNvPr id="3" name="Slide three title">
             <a:extLst xmlns:a="http://schemas.openxmlformats.org/drawingml/2006/main">
               <a:ext uri="{FF2B5EF4-FFF2-40B4-BE49-F238E27FC236}">
-                <a16:creationId xmlns:a16="http://schemas.microsoft.com/office/drawing/2014/main" id="{BAFE47F9-60AE-4EC0-95C3-909FB22545CD}"/>
+                <a16:creationId xmlns:a16="http://schemas.microsoft.com/office/drawing/2014/main" id="{49F63AB6-A2D9-4419-842E-C5853F76A953}"/>
               </a:ext>
             </a:extLst>
           </p:cNvPr>
@@ -1712,7 +1712,7 @@
           <p:cNvPr id="2" name="Slide three text">
             <a:extLst xmlns:a="http://schemas.openxmlformats.org/drawingml/2006/main">
               <a:ext uri="{FF2B5EF4-FFF2-40B4-BE49-F238E27FC236}">
-                <a16:creationId xmlns:a16="http://schemas.microsoft.com/office/drawing/2014/main" id="{E9E3234A-83DF-406E-A65D-2F68AB3B83A3}"/>
+                <a16:creationId xmlns:a16="http://schemas.microsoft.com/office/drawing/2014/main" id="{2495BCE2-1C5B-465C-A014-9A3DFA619CAD}"/>
               </a:ext>
             </a:extLst>
           </p:cNvPr>
@@ -1766,7 +1766,7 @@
     </p:spTree>
     <p:extLst>
       <p:ext uri="{BB962C8B-B14F-4D97-AF65-F5344CB8AC3E}">
-        <p14:creationId xmlns:p14="http://schemas.microsoft.com/office/powerpoint/2010/main" val="2089011195"/>
+        <p14:creationId xmlns:p14="http://schemas.microsoft.com/office/powerpoint/2010/main" val="1279642551"/>
       </p:ext>
     </p:extLst>
   </p:cSld>

</xml_diff>

<commit_message>
feat: update document engines
</commit_message>
<xml_diff>
--- a/crates/opensuite-pptx/tests/fixtures/realistic-presentation.pptx
+++ b/crates/opensuite-pptx/tests/fixtures/realistic-presentation.pptx
@@ -2,15 +2,15 @@
 <file path=ppt/presentation.xml><?xml version="1.0" encoding="utf-8"?>
 <p:presentation xmlns:p="http://schemas.openxmlformats.org/presentationml/2006/main">
   <p:sldMasterIdLst>
-    <p:sldMasterId xmlns:r="http://schemas.openxmlformats.org/officeDocument/2006/relationships" id="2147483648" r:id="R5e9524203d054624"/>
+    <p:sldMasterId xmlns:r="http://schemas.openxmlformats.org/officeDocument/2006/relationships" id="2147483648" r:id="R6c8aba9628294a1a"/>
   </p:sldMasterIdLst>
   <p:notesMasterIdLst>
-    <p:notesMasterId xmlns:r="http://schemas.openxmlformats.org/officeDocument/2006/relationships" r:id="R5a971240d0a44ef9"/>
+    <p:notesMasterId xmlns:r="http://schemas.openxmlformats.org/officeDocument/2006/relationships" r:id="R0467c0a6364b4510"/>
   </p:notesMasterIdLst>
   <p:sldIdLst>
-    <p:sldId xmlns:r="http://schemas.openxmlformats.org/officeDocument/2006/relationships" id="256" r:id="R75283acdb9df4d74"/>
-    <p:sldId xmlns:r="http://schemas.openxmlformats.org/officeDocument/2006/relationships" id="257" r:id="Rf62530cec28b4f4a"/>
-    <p:sldId xmlns:r="http://schemas.openxmlformats.org/officeDocument/2006/relationships" id="258" r:id="R670978202e4f4325"/>
+    <p:sldId xmlns:r="http://schemas.openxmlformats.org/officeDocument/2006/relationships" id="256" r:id="R29e026fbc87447bd"/>
+    <p:sldId xmlns:r="http://schemas.openxmlformats.org/officeDocument/2006/relationships" id="257" r:id="Rf32fe798ac2c45ab"/>
+    <p:sldId xmlns:r="http://schemas.openxmlformats.org/officeDocument/2006/relationships" id="258" r:id="R692790ba10454081"/>
   </p:sldIdLst>
   <p:sldSz cx="12192000" cy="6858000"/>
   <p:notesSz cx="6858000" cy="9144000"/>
@@ -640,7 +640,7 @@
   </p:cSld>
   <p:clrMap bg1="lt1" tx1="dk1" bg2="lt2" tx2="dk2" accent1="accent1" accent2="accent2" accent3="accent3" accent4="accent4" accent5="accent5" accent6="accent6" hlink="hlink" folHlink="folHlink"/>
   <p:sldLayoutIdLst>
-    <p:sldLayoutId xmlns:r="http://schemas.openxmlformats.org/officeDocument/2006/relationships" id="2147483649" r:id="R6e82f834890d4d21"/>
+    <p:sldLayoutId xmlns:r="http://schemas.openxmlformats.org/officeDocument/2006/relationships" id="2147483649" r:id="R3602bcd9c21a47d5"/>
   </p:sldLayoutIdLst>
   <p:txStyles>
     <p:titleStyle>
@@ -1321,10 +1321,10 @@
       </p:grpSpPr>
       <p:sp>
         <p:nvSpPr>
-          <p:cNvPr id="4" name="Title placeholder">
+          <p:cNvPr id="5" name="Title placeholder">
             <a:extLst xmlns:a="http://schemas.openxmlformats.org/drawingml/2006/main">
               <a:ext uri="{FF2B5EF4-FFF2-40B4-BE49-F238E27FC236}">
-                <a16:creationId xmlns:a16="http://schemas.microsoft.com/office/drawing/2014/main" id="{93E4EDB8-D626-480C-B1D0-86BB8DB01F6F}"/>
+                <a16:creationId xmlns:a16="http://schemas.microsoft.com/office/drawing/2014/main" id="{5FC9F1A1-444A-42C6-9C5D-5D471B903056}"/>
               </a:ext>
             </a:extLst>
           </p:cNvPr>
@@ -1380,7 +1380,7 @@
           <p:cNvPr id="2" name="Body placeholder">
             <a:extLst xmlns:a="http://schemas.openxmlformats.org/drawingml/2006/main">
               <a:ext uri="{FF2B5EF4-FFF2-40B4-BE49-F238E27FC236}">
-                <a16:creationId xmlns:a16="http://schemas.microsoft.com/office/drawing/2014/main" id="{0B4E966E-730F-4AC9-B36D-19622C3901DE}"/>
+                <a16:creationId xmlns:a16="http://schemas.microsoft.com/office/drawing/2014/main" id="{19D3D1B6-B69D-4C33-93F2-6C8DCD05B24E}"/>
               </a:ext>
             </a:extLst>
           </p:cNvPr>
@@ -1465,9 +1465,34 @@
           </a:p>
         </p:txBody>
       </p:sp>
+      <p:pic>
+        <p:nvPicPr>
+          <p:cNvPr id="7" name=""/>
+          <p:cNvPicPr>
+            <a:picLocks xmlns:a="http://schemas.openxmlformats.org/drawingml/2006/main" noChangeAspect="1"/>
+          </p:cNvPicPr>
+          <p:nvPr/>
+        </p:nvPicPr>
+        <p:blipFill>
+          <a:blip xmlns:r="http://schemas.openxmlformats.org/officeDocument/2006/relationships" xmlns:a="http://schemas.openxmlformats.org/drawingml/2006/main" r:embed="R80f47edde5794491"/>
+          <a:srcRect xmlns:a="http://schemas.openxmlformats.org/drawingml/2006/main" l="341" t="0" r="341" b="0"/>
+          <a:stretch xmlns:a="http://schemas.openxmlformats.org/drawingml/2006/main">
+            <a:fillRect l="0" t="0" r="0" b="0"/>
+          </a:stretch>
+        </p:blipFill>
+        <p:spPr>
+          <a:xfrm xmlns:a="http://schemas.openxmlformats.org/drawingml/2006/main">
+            <a:off x="800100" y="3714750"/>
+            <a:ext cx="2857500" cy="1619250"/>
+          </a:xfrm>
+          <a:prstGeom xmlns:a="http://schemas.openxmlformats.org/drawingml/2006/main" prst="rect">
+            <a:avLst/>
+          </a:prstGeom>
+        </p:spPr>
+      </p:pic>
       <p:graphicFrame>
         <p:nvGraphicFramePr>
-          <p:cNvPr id="6" name="Chart"/>
+          <p:cNvPr id="8" name="Chart"/>
           <p:cNvGraphicFramePr/>
           <p:nvPr/>
         </p:nvGraphicFramePr>
@@ -1477,14 +1502,14 @@
         </p:xfrm>
         <a:graphic xmlns:a="http://schemas.openxmlformats.org/drawingml/2006/main">
           <a:graphicData uri="http://schemas.openxmlformats.org/drawingml/2006/chart">
-            <c:chart xmlns:r="http://schemas.openxmlformats.org/officeDocument/2006/relationships" xmlns:c="http://schemas.openxmlformats.org/drawingml/2006/chart" r:id="R1404b4c5d2ae4ace"/>
+            <c:chart xmlns:r="http://schemas.openxmlformats.org/officeDocument/2006/relationships" xmlns:c="http://schemas.openxmlformats.org/drawingml/2006/chart" r:id="R8ec473e57ee640ee"/>
           </a:graphicData>
         </a:graphic>
       </p:graphicFrame>
     </p:spTree>
     <p:extLst>
       <p:ext uri="{BB962C8B-B14F-4D97-AF65-F5344CB8AC3E}">
-        <p14:creationId xmlns:p14="http://schemas.microsoft.com/office/powerpoint/2010/main" val="630832148"/>
+        <p14:creationId xmlns:p14="http://schemas.microsoft.com/office/powerpoint/2010/main" val="2083003186"/>
       </p:ext>
     </p:extLst>
   </p:cSld>
@@ -1515,7 +1540,7 @@
           <p:cNvPr id="3" name="Slide two title">
             <a:extLst xmlns:a="http://schemas.openxmlformats.org/drawingml/2006/main">
               <a:ext uri="{FF2B5EF4-FFF2-40B4-BE49-F238E27FC236}">
-                <a16:creationId xmlns:a16="http://schemas.microsoft.com/office/drawing/2014/main" id="{AABB12F9-701E-4298-A6B5-32F0BE21F436}"/>
+                <a16:creationId xmlns:a16="http://schemas.microsoft.com/office/drawing/2014/main" id="{0E948984-2610-4015-9D97-E94B9AEB8D1B}"/>
               </a:ext>
             </a:extLst>
           </p:cNvPr>
@@ -1571,7 +1596,7 @@
           <p:cNvPr id="2" name="Slide two text">
             <a:extLst xmlns:a="http://schemas.openxmlformats.org/drawingml/2006/main">
               <a:ext uri="{FF2B5EF4-FFF2-40B4-BE49-F238E27FC236}">
-                <a16:creationId xmlns:a16="http://schemas.microsoft.com/office/drawing/2014/main" id="{E7306193-C6B6-4E2F-9E20-9F4FB4FA6480}"/>
+                <a16:creationId xmlns:a16="http://schemas.microsoft.com/office/drawing/2014/main" id="{491FEF60-BA3F-4121-AA2E-7B0C1D05A9A8}"/>
               </a:ext>
             </a:extLst>
           </p:cNvPr>
@@ -1625,7 +1650,7 @@
     </p:spTree>
     <p:extLst>
       <p:ext uri="{BB962C8B-B14F-4D97-AF65-F5344CB8AC3E}">
-        <p14:creationId xmlns:p14="http://schemas.microsoft.com/office/powerpoint/2010/main" val="904966072"/>
+        <p14:creationId xmlns:p14="http://schemas.microsoft.com/office/powerpoint/2010/main" val="338326486"/>
       </p:ext>
     </p:extLst>
   </p:cSld>
@@ -1656,7 +1681,7 @@
           <p:cNvPr id="3" name="Slide three title">
             <a:extLst xmlns:a="http://schemas.openxmlformats.org/drawingml/2006/main">
               <a:ext uri="{FF2B5EF4-FFF2-40B4-BE49-F238E27FC236}">
-                <a16:creationId xmlns:a16="http://schemas.microsoft.com/office/drawing/2014/main" id="{49F63AB6-A2D9-4419-842E-C5853F76A953}"/>
+                <a16:creationId xmlns:a16="http://schemas.microsoft.com/office/drawing/2014/main" id="{4BC750CA-B6EB-41BF-9193-AEC7B96D77B8}"/>
               </a:ext>
             </a:extLst>
           </p:cNvPr>
@@ -1712,7 +1737,7 @@
           <p:cNvPr id="2" name="Slide three text">
             <a:extLst xmlns:a="http://schemas.openxmlformats.org/drawingml/2006/main">
               <a:ext uri="{FF2B5EF4-FFF2-40B4-BE49-F238E27FC236}">
-                <a16:creationId xmlns:a16="http://schemas.microsoft.com/office/drawing/2014/main" id="{2495BCE2-1C5B-465C-A014-9A3DFA619CAD}"/>
+                <a16:creationId xmlns:a16="http://schemas.microsoft.com/office/drawing/2014/main" id="{9EF5D991-321E-4C85-A000-406E5E574DC3}"/>
               </a:ext>
             </a:extLst>
           </p:cNvPr>
@@ -1766,7 +1791,7 @@
     </p:spTree>
     <p:extLst>
       <p:ext uri="{BB962C8B-B14F-4D97-AF65-F5344CB8AC3E}">
-        <p14:creationId xmlns:p14="http://schemas.microsoft.com/office/powerpoint/2010/main" val="1279642551"/>
+        <p14:creationId xmlns:p14="http://schemas.microsoft.com/office/powerpoint/2010/main" val="1909900338"/>
       </p:ext>
     </p:extLst>
   </p:cSld>

</xml_diff>